<commit_message>
docs: correct stale example figures in presentation deck
Co-Authored-By: Claude Sonnet 5 <noreply@anthropic.com>
</commit_message>
<xml_diff>
--- a/docs/EV_LOGISTICS_SERVICE_PRESENTATION.pptx
+++ b/docs/EV_LOGISTICS_SERVICE_PRESENTATION.pptx
@@ -5711,7 +5711,7 @@
               </a:defRPr>
             </a:pPr>
             <a:r>
-              <a:t>테스트 결과</a:t>
+              <a:t>기준 시나리오</a:t>
             </a:r>
           </a:p>
         </p:txBody>
@@ -5747,7 +5747,7 @@
               </a:defRPr>
             </a:pPr>
             <a:r>
-              <a:t>약 537.1kWh</a:t>
+              <a:t>약 378kWh</a:t>
             </a:r>
           </a:p>
         </p:txBody>
@@ -11346,7 +11346,7 @@
               </a:defRPr>
             </a:pPr>
             <a:r>
-              <a:t>7호차 (Volvo FH)</a:t>
+              <a:t>5호차 (Volvo FH)</a:t>
             </a:r>
           </a:p>
         </p:txBody>
@@ -11508,7 +11508,7 @@
               </a:defRPr>
             </a:pPr>
             <a:r>
-              <a:t>65% · 안전 기준 10%</a:t>
+              <a:t>80% · 안전 기준 10%</a:t>
             </a:r>
           </a:p>
         </p:txBody>
@@ -11670,7 +11670,7 @@
               </a:defRPr>
             </a:pPr>
             <a:r>
-              <a:t>8박스 / 총 80kg</a:t>
+              <a:t>9박스 / 총 90kg</a:t>
             </a:r>
           </a:p>
         </p:txBody>
@@ -11994,7 +11994,7 @@
               </a:defRPr>
             </a:pPr>
             <a:r>
-              <a:t>10:00 → 16:42</a:t>
+              <a:t>10:00 → 18:56</a:t>
             </a:r>
           </a:p>
         </p:txBody>
@@ -12156,7 +12156,7 @@
               </a:defRPr>
             </a:pPr>
             <a:r>
-              <a:t>537.1kWh</a:t>
+              <a:t>542.7kWh</a:t>
             </a:r>
           </a:p>
         </p:txBody>
@@ -13044,7 +13044,7 @@
               </a:defRPr>
             </a:pPr>
             <a:r>
-              <a:t>기본 변수: 속도, 화물량, 온도, HVAC, 경사, 운전성향, 타이어 공기압, 거리</a:t>
+              <a:t>기본 변수: 속도, 화물량, 외기온도, 배터리온도, HVAC, 경사, 운전성향, 타이어 공기압, 거리</a:t>
             </a:r>
           </a:p>
           <a:p>

</xml_diff>